<commit_message>
Support de soutenance : ajoute le binome sur la diapositive de titre
</commit_message>
<xml_diff>
--- a/docs/Soutenance_QuizArena.pptx
+++ b/docs/Soutenance_QuizArena.pptx
@@ -513,7 +513,7 @@
           <a:p>
             <a:r>
               <a:rPr lang="en-US" dirty="0"/>
-              <a:t>Bonjour à tous. Je vais vous présenter QuizArena, mon projet de jeu multijoueur : un quiz de culture générale en mode battle royale, jouable de 2 à 8 joueurs. C'est à la fois un jeu synchrone, un projet full-stack complet (client lourd, API, base de données) et un produit fini, testé et livré sous le tag v1.0-demo.</a:t>
+              <a:t>Bonjour à tous. Nous allons vous présenter QuizArena, notre projet de jeu multijoueur : un quiz de culture générale en mode battle royale, jouable de 2 à 8 joueurs. C'est à la fois un jeu synchrone, un projet full-stack complet (client lourd, API, base de données) et un produit fini, testé et livré sous le tag v1.0-demo.</a:t>
             </a:r>
             <a:endParaRPr lang="en-US" dirty="0"/>
           </a:p>
@@ -2281,7 +2281,7 @@
                 <a:ea typeface="Arial" pitchFamily="34" charset="-122"/>
                 <a:cs typeface="Arial" pitchFamily="34" charset="-120"/>
               </a:rPr>
-              <a:t>Adham Marrakchi     •     Soutenance du projet multijoueur     •     version v1.0-demo</a:t>
+              <a:t>Adham Marrakchi  &amp;  Ghizlane Benallal     •     Soutenance du projet multijoueur     •     v1.0-demo</a:t>
             </a:r>
             <a:endParaRPr lang="en-US" sz="1250" dirty="0"/>
           </a:p>

</xml_diff>